<commit_message>
Polish lesson 2 visual deck
</commit_message>
<xml_diff>
--- a/decks/lesson-02-custom-prompts-at-scale.pptx
+++ b/decks/lesson-02-custom-prompts-at-scale.pptx
@@ -2,22 +2,22 @@
 <file path=ppt/presentation.xml><?xml version="1.0" encoding="utf-8"?>
 <p:presentation xmlns:p="http://schemas.openxmlformats.org/presentationml/2006/main">
   <p:sldMasterIdLst>
-    <p:sldMasterId xmlns:r="http://schemas.openxmlformats.org/officeDocument/2006/relationships" id="2147483648" r:id="Rb5901e657b0f4d6a"/>
+    <p:sldMasterId xmlns:r="http://schemas.openxmlformats.org/officeDocument/2006/relationships" id="2147483648" r:id="R414bb9a681f4464a"/>
   </p:sldMasterIdLst>
   <p:notesMasterIdLst>
-    <p:notesMasterId xmlns:r="http://schemas.openxmlformats.org/officeDocument/2006/relationships" r:id="R1c61152236bd4961"/>
+    <p:notesMasterId xmlns:r="http://schemas.openxmlformats.org/officeDocument/2006/relationships" r:id="R5590a5d6e8184f4d"/>
   </p:notesMasterIdLst>
   <p:sldIdLst>
-    <p:sldId xmlns:r="http://schemas.openxmlformats.org/officeDocument/2006/relationships" id="256" r:id="R326cbb85ecc4466d"/>
-    <p:sldId xmlns:r="http://schemas.openxmlformats.org/officeDocument/2006/relationships" id="257" r:id="Rb1d03798a901406c"/>
-    <p:sldId xmlns:r="http://schemas.openxmlformats.org/officeDocument/2006/relationships" id="258" r:id="R83d7b3bb28704ac3"/>
-    <p:sldId xmlns:r="http://schemas.openxmlformats.org/officeDocument/2006/relationships" id="259" r:id="Rf4b82bf95fbb48e8"/>
-    <p:sldId xmlns:r="http://schemas.openxmlformats.org/officeDocument/2006/relationships" id="260" r:id="R397e1f775be04fd5"/>
-    <p:sldId xmlns:r="http://schemas.openxmlformats.org/officeDocument/2006/relationships" id="261" r:id="Rbfc88dc7d0654874"/>
-    <p:sldId xmlns:r="http://schemas.openxmlformats.org/officeDocument/2006/relationships" id="262" r:id="R62d8b56bf57243d8"/>
-    <p:sldId xmlns:r="http://schemas.openxmlformats.org/officeDocument/2006/relationships" id="263" r:id="R660b8cec0ad54cd8"/>
-    <p:sldId xmlns:r="http://schemas.openxmlformats.org/officeDocument/2006/relationships" id="264" r:id="R55ac65f3712e4505"/>
-    <p:sldId xmlns:r="http://schemas.openxmlformats.org/officeDocument/2006/relationships" id="265" r:id="R9ac87621ad954d5c"/>
+    <p:sldId xmlns:r="http://schemas.openxmlformats.org/officeDocument/2006/relationships" id="256" r:id="R4e2e04c7da124507"/>
+    <p:sldId xmlns:r="http://schemas.openxmlformats.org/officeDocument/2006/relationships" id="257" r:id="R8a9c54c61bf0473a"/>
+    <p:sldId xmlns:r="http://schemas.openxmlformats.org/officeDocument/2006/relationships" id="258" r:id="Rdae1f8e9ffe340a9"/>
+    <p:sldId xmlns:r="http://schemas.openxmlformats.org/officeDocument/2006/relationships" id="259" r:id="R3e01abfc62fc444a"/>
+    <p:sldId xmlns:r="http://schemas.openxmlformats.org/officeDocument/2006/relationships" id="260" r:id="R2094b4ef3742423a"/>
+    <p:sldId xmlns:r="http://schemas.openxmlformats.org/officeDocument/2006/relationships" id="261" r:id="Rea843e17e6084bb7"/>
+    <p:sldId xmlns:r="http://schemas.openxmlformats.org/officeDocument/2006/relationships" id="262" r:id="R9ea96b418ec045ae"/>
+    <p:sldId xmlns:r="http://schemas.openxmlformats.org/officeDocument/2006/relationships" id="263" r:id="R7ba5ecfe008b43c1"/>
+    <p:sldId xmlns:r="http://schemas.openxmlformats.org/officeDocument/2006/relationships" id="264" r:id="Rfdf81ddecba14656"/>
+    <p:sldId xmlns:r="http://schemas.openxmlformats.org/officeDocument/2006/relationships" id="265" r:id="R3a0d9b3cd60f4f8c"/>
   </p:sldIdLst>
   <p:sldSz cx="12192000" cy="6858000"/>
   <p:notesSz cx="6858000" cy="9144000"/>
@@ -1244,7 +1244,7 @@
   </p:cSld>
   <p:clrMap bg1="lt1" tx1="dk1" bg2="lt2" tx2="dk2" accent1="accent1" accent2="accent2" accent3="accent3" accent4="accent4" accent5="accent5" accent6="accent6" hlink="hlink" folHlink="folHlink"/>
   <p:sldLayoutIdLst>
-    <p:sldLayoutId xmlns:r="http://schemas.openxmlformats.org/officeDocument/2006/relationships" id="2147483649" r:id="R40dee4ae066340a9"/>
+    <p:sldLayoutId xmlns:r="http://schemas.openxmlformats.org/officeDocument/2006/relationships" id="2147483649" r:id="R4b1ecde082de4db2"/>
   </p:sldLayoutIdLst>
   <p:txStyles>
     <p:titleStyle>
@@ -1799,7 +1799,7 @@
           <p:nvPr/>
         </p:nvPicPr>
         <p:blipFill>
-          <a:blip xmlns:r="http://schemas.openxmlformats.org/officeDocument/2006/relationships" xmlns:a="http://schemas.openxmlformats.org/drawingml/2006/main" r:embed="R6ae9047348dc4625"/>
+          <a:blip xmlns:r="http://schemas.openxmlformats.org/officeDocument/2006/relationships" xmlns:a="http://schemas.openxmlformats.org/drawingml/2006/main" r:embed="Rda51026ce67044ac"/>
           <a:stretch xmlns:a="http://schemas.openxmlformats.org/drawingml/2006/main"/>
         </p:blipFill>
         <p:spPr>
@@ -1815,7 +1815,7 @@
     </p:spTree>
     <p:extLst>
       <p:ext uri="{BB962C8B-B14F-4D97-AF65-F5344CB8AC3E}">
-        <p14:creationId xmlns:p14="http://schemas.microsoft.com/office/powerpoint/2010/main" val="260265912"/>
+        <p14:creationId xmlns:p14="http://schemas.microsoft.com/office/powerpoint/2010/main" val="1434409942"/>
       </p:ext>
     </p:extLst>
   </p:cSld>
@@ -1850,7 +1850,7 @@
           <p:nvPr/>
         </p:nvPicPr>
         <p:blipFill>
-          <a:blip xmlns:r="http://schemas.openxmlformats.org/officeDocument/2006/relationships" xmlns:a="http://schemas.openxmlformats.org/drawingml/2006/main" r:embed="R66bc18ba2a8748e0"/>
+          <a:blip xmlns:r="http://schemas.openxmlformats.org/officeDocument/2006/relationships" xmlns:a="http://schemas.openxmlformats.org/drawingml/2006/main" r:embed="R8b130f9612454945"/>
           <a:stretch xmlns:a="http://schemas.openxmlformats.org/drawingml/2006/main"/>
         </p:blipFill>
         <p:spPr>
@@ -1866,7 +1866,7 @@
     </p:spTree>
     <p:extLst>
       <p:ext uri="{BB962C8B-B14F-4D97-AF65-F5344CB8AC3E}">
-        <p14:creationId xmlns:p14="http://schemas.microsoft.com/office/powerpoint/2010/main" val="1802960180"/>
+        <p14:creationId xmlns:p14="http://schemas.microsoft.com/office/powerpoint/2010/main" val="1224810254"/>
       </p:ext>
     </p:extLst>
   </p:cSld>
@@ -1901,7 +1901,7 @@
           <p:nvPr/>
         </p:nvPicPr>
         <p:blipFill>
-          <a:blip xmlns:r="http://schemas.openxmlformats.org/officeDocument/2006/relationships" xmlns:a="http://schemas.openxmlformats.org/drawingml/2006/main" r:embed="Rbfef3792b13c4428"/>
+          <a:blip xmlns:r="http://schemas.openxmlformats.org/officeDocument/2006/relationships" xmlns:a="http://schemas.openxmlformats.org/drawingml/2006/main" r:embed="R7fb296632b3c4555"/>
           <a:stretch xmlns:a="http://schemas.openxmlformats.org/drawingml/2006/main"/>
         </p:blipFill>
         <p:spPr>
@@ -1917,7 +1917,7 @@
     </p:spTree>
     <p:extLst>
       <p:ext uri="{BB962C8B-B14F-4D97-AF65-F5344CB8AC3E}">
-        <p14:creationId xmlns:p14="http://schemas.microsoft.com/office/powerpoint/2010/main" val="1669107915"/>
+        <p14:creationId xmlns:p14="http://schemas.microsoft.com/office/powerpoint/2010/main" val="849229220"/>
       </p:ext>
     </p:extLst>
   </p:cSld>
@@ -1952,7 +1952,7 @@
           <p:nvPr/>
         </p:nvPicPr>
         <p:blipFill>
-          <a:blip xmlns:r="http://schemas.openxmlformats.org/officeDocument/2006/relationships" xmlns:a="http://schemas.openxmlformats.org/drawingml/2006/main" r:embed="R9a7887b7414b4163"/>
+          <a:blip xmlns:r="http://schemas.openxmlformats.org/officeDocument/2006/relationships" xmlns:a="http://schemas.openxmlformats.org/drawingml/2006/main" r:embed="R6518b76d61864880"/>
           <a:stretch xmlns:a="http://schemas.openxmlformats.org/drawingml/2006/main"/>
         </p:blipFill>
         <p:spPr>
@@ -1968,7 +1968,7 @@
     </p:spTree>
     <p:extLst>
       <p:ext uri="{BB962C8B-B14F-4D97-AF65-F5344CB8AC3E}">
-        <p14:creationId xmlns:p14="http://schemas.microsoft.com/office/powerpoint/2010/main" val="54596575"/>
+        <p14:creationId xmlns:p14="http://schemas.microsoft.com/office/powerpoint/2010/main" val="1139984199"/>
       </p:ext>
     </p:extLst>
   </p:cSld>
@@ -2003,7 +2003,7 @@
           <p:nvPr/>
         </p:nvPicPr>
         <p:blipFill>
-          <a:blip xmlns:r="http://schemas.openxmlformats.org/officeDocument/2006/relationships" xmlns:a="http://schemas.openxmlformats.org/drawingml/2006/main" r:embed="R09944096b14f448a"/>
+          <a:blip xmlns:r="http://schemas.openxmlformats.org/officeDocument/2006/relationships" xmlns:a="http://schemas.openxmlformats.org/drawingml/2006/main" r:embed="R9613a76ca9c44499"/>
           <a:stretch xmlns:a="http://schemas.openxmlformats.org/drawingml/2006/main"/>
         </p:blipFill>
         <p:spPr>
@@ -2019,7 +2019,7 @@
     </p:spTree>
     <p:extLst>
       <p:ext uri="{BB962C8B-B14F-4D97-AF65-F5344CB8AC3E}">
-        <p14:creationId xmlns:p14="http://schemas.microsoft.com/office/powerpoint/2010/main" val="2103968313"/>
+        <p14:creationId xmlns:p14="http://schemas.microsoft.com/office/powerpoint/2010/main" val="1036447640"/>
       </p:ext>
     </p:extLst>
   </p:cSld>
@@ -2054,7 +2054,7 @@
           <p:nvPr/>
         </p:nvPicPr>
         <p:blipFill>
-          <a:blip xmlns:r="http://schemas.openxmlformats.org/officeDocument/2006/relationships" xmlns:a="http://schemas.openxmlformats.org/drawingml/2006/main" r:embed="Rd3f77d3473ed45df"/>
+          <a:blip xmlns:r="http://schemas.openxmlformats.org/officeDocument/2006/relationships" xmlns:a="http://schemas.openxmlformats.org/drawingml/2006/main" r:embed="R5686607bb47543a3"/>
           <a:stretch xmlns:a="http://schemas.openxmlformats.org/drawingml/2006/main"/>
         </p:blipFill>
         <p:spPr>
@@ -2070,7 +2070,7 @@
     </p:spTree>
     <p:extLst>
       <p:ext uri="{BB962C8B-B14F-4D97-AF65-F5344CB8AC3E}">
-        <p14:creationId xmlns:p14="http://schemas.microsoft.com/office/powerpoint/2010/main" val="339945172"/>
+        <p14:creationId xmlns:p14="http://schemas.microsoft.com/office/powerpoint/2010/main" val="1861133344"/>
       </p:ext>
     </p:extLst>
   </p:cSld>
@@ -2105,7 +2105,7 @@
           <p:nvPr/>
         </p:nvPicPr>
         <p:blipFill>
-          <a:blip xmlns:r="http://schemas.openxmlformats.org/officeDocument/2006/relationships" xmlns:a="http://schemas.openxmlformats.org/drawingml/2006/main" r:embed="Rf25a31f83885474d"/>
+          <a:blip xmlns:r="http://schemas.openxmlformats.org/officeDocument/2006/relationships" xmlns:a="http://schemas.openxmlformats.org/drawingml/2006/main" r:embed="Rfade758a1f934421"/>
           <a:stretch xmlns:a="http://schemas.openxmlformats.org/drawingml/2006/main"/>
         </p:blipFill>
         <p:spPr>
@@ -2121,7 +2121,7 @@
     </p:spTree>
     <p:extLst>
       <p:ext uri="{BB962C8B-B14F-4D97-AF65-F5344CB8AC3E}">
-        <p14:creationId xmlns:p14="http://schemas.microsoft.com/office/powerpoint/2010/main" val="1948530154"/>
+        <p14:creationId xmlns:p14="http://schemas.microsoft.com/office/powerpoint/2010/main" val="597908338"/>
       </p:ext>
     </p:extLst>
   </p:cSld>
@@ -2156,7 +2156,7 @@
           <p:nvPr/>
         </p:nvPicPr>
         <p:blipFill>
-          <a:blip xmlns:r="http://schemas.openxmlformats.org/officeDocument/2006/relationships" xmlns:a="http://schemas.openxmlformats.org/drawingml/2006/main" r:embed="R3be35bc4be66481f"/>
+          <a:blip xmlns:r="http://schemas.openxmlformats.org/officeDocument/2006/relationships" xmlns:a="http://schemas.openxmlformats.org/drawingml/2006/main" r:embed="R9a635c348d674632"/>
           <a:stretch xmlns:a="http://schemas.openxmlformats.org/drawingml/2006/main"/>
         </p:blipFill>
         <p:spPr>
@@ -2172,7 +2172,7 @@
     </p:spTree>
     <p:extLst>
       <p:ext uri="{BB962C8B-B14F-4D97-AF65-F5344CB8AC3E}">
-        <p14:creationId xmlns:p14="http://schemas.microsoft.com/office/powerpoint/2010/main" val="973554938"/>
+        <p14:creationId xmlns:p14="http://schemas.microsoft.com/office/powerpoint/2010/main" val="1009109976"/>
       </p:ext>
     </p:extLst>
   </p:cSld>
@@ -2207,7 +2207,7 @@
           <p:nvPr/>
         </p:nvPicPr>
         <p:blipFill>
-          <a:blip xmlns:r="http://schemas.openxmlformats.org/officeDocument/2006/relationships" xmlns:a="http://schemas.openxmlformats.org/drawingml/2006/main" r:embed="R2b303d7304314256"/>
+          <a:blip xmlns:r="http://schemas.openxmlformats.org/officeDocument/2006/relationships" xmlns:a="http://schemas.openxmlformats.org/drawingml/2006/main" r:embed="R922b644e53764d3e"/>
           <a:stretch xmlns:a="http://schemas.openxmlformats.org/drawingml/2006/main"/>
         </p:blipFill>
         <p:spPr>
@@ -2223,7 +2223,7 @@
     </p:spTree>
     <p:extLst>
       <p:ext uri="{BB962C8B-B14F-4D97-AF65-F5344CB8AC3E}">
-        <p14:creationId xmlns:p14="http://schemas.microsoft.com/office/powerpoint/2010/main" val="1562722853"/>
+        <p14:creationId xmlns:p14="http://schemas.microsoft.com/office/powerpoint/2010/main" val="1755097069"/>
       </p:ext>
     </p:extLst>
   </p:cSld>
@@ -2258,7 +2258,7 @@
           <p:nvPr/>
         </p:nvPicPr>
         <p:blipFill>
-          <a:blip xmlns:r="http://schemas.openxmlformats.org/officeDocument/2006/relationships" xmlns:a="http://schemas.openxmlformats.org/drawingml/2006/main" r:embed="Rf30ada70453f467b"/>
+          <a:blip xmlns:r="http://schemas.openxmlformats.org/officeDocument/2006/relationships" xmlns:a="http://schemas.openxmlformats.org/drawingml/2006/main" r:embed="Rd52a205ad83c489d"/>
           <a:stretch xmlns:a="http://schemas.openxmlformats.org/drawingml/2006/main"/>
         </p:blipFill>
         <p:spPr>
@@ -2274,7 +2274,7 @@
     </p:spTree>
     <p:extLst>
       <p:ext uri="{BB962C8B-B14F-4D97-AF65-F5344CB8AC3E}">
-        <p14:creationId xmlns:p14="http://schemas.microsoft.com/office/powerpoint/2010/main" val="748289431"/>
+        <p14:creationId xmlns:p14="http://schemas.microsoft.com/office/powerpoint/2010/main" val="654273764"/>
       </p:ext>
     </p:extLst>
   </p:cSld>

</xml_diff>

<commit_message>
Restyle lesson 2 infographic visuals
</commit_message>
<xml_diff>
--- a/decks/lesson-02-custom-prompts-at-scale.pptx
+++ b/decks/lesson-02-custom-prompts-at-scale.pptx
@@ -2,22 +2,22 @@
 <file path=ppt/presentation.xml><?xml version="1.0" encoding="utf-8"?>
 <p:presentation xmlns:p="http://schemas.openxmlformats.org/presentationml/2006/main">
   <p:sldMasterIdLst>
-    <p:sldMasterId xmlns:r="http://schemas.openxmlformats.org/officeDocument/2006/relationships" id="2147483648" r:id="R414bb9a681f4464a"/>
+    <p:sldMasterId xmlns:r="http://schemas.openxmlformats.org/officeDocument/2006/relationships" id="2147483648" r:id="R15d2ec145ff7477a"/>
   </p:sldMasterIdLst>
   <p:notesMasterIdLst>
-    <p:notesMasterId xmlns:r="http://schemas.openxmlformats.org/officeDocument/2006/relationships" r:id="R5590a5d6e8184f4d"/>
+    <p:notesMasterId xmlns:r="http://schemas.openxmlformats.org/officeDocument/2006/relationships" r:id="R5345b29caffb41b0"/>
   </p:notesMasterIdLst>
   <p:sldIdLst>
-    <p:sldId xmlns:r="http://schemas.openxmlformats.org/officeDocument/2006/relationships" id="256" r:id="R4e2e04c7da124507"/>
-    <p:sldId xmlns:r="http://schemas.openxmlformats.org/officeDocument/2006/relationships" id="257" r:id="R8a9c54c61bf0473a"/>
-    <p:sldId xmlns:r="http://schemas.openxmlformats.org/officeDocument/2006/relationships" id="258" r:id="Rdae1f8e9ffe340a9"/>
-    <p:sldId xmlns:r="http://schemas.openxmlformats.org/officeDocument/2006/relationships" id="259" r:id="R3e01abfc62fc444a"/>
-    <p:sldId xmlns:r="http://schemas.openxmlformats.org/officeDocument/2006/relationships" id="260" r:id="R2094b4ef3742423a"/>
-    <p:sldId xmlns:r="http://schemas.openxmlformats.org/officeDocument/2006/relationships" id="261" r:id="Rea843e17e6084bb7"/>
-    <p:sldId xmlns:r="http://schemas.openxmlformats.org/officeDocument/2006/relationships" id="262" r:id="R9ea96b418ec045ae"/>
-    <p:sldId xmlns:r="http://schemas.openxmlformats.org/officeDocument/2006/relationships" id="263" r:id="R7ba5ecfe008b43c1"/>
-    <p:sldId xmlns:r="http://schemas.openxmlformats.org/officeDocument/2006/relationships" id="264" r:id="Rfdf81ddecba14656"/>
-    <p:sldId xmlns:r="http://schemas.openxmlformats.org/officeDocument/2006/relationships" id="265" r:id="R3a0d9b3cd60f4f8c"/>
+    <p:sldId xmlns:r="http://schemas.openxmlformats.org/officeDocument/2006/relationships" id="256" r:id="Reb2f957008a84207"/>
+    <p:sldId xmlns:r="http://schemas.openxmlformats.org/officeDocument/2006/relationships" id="257" r:id="R65ce89cf1f694221"/>
+    <p:sldId xmlns:r="http://schemas.openxmlformats.org/officeDocument/2006/relationships" id="258" r:id="Reb03753fc92c4290"/>
+    <p:sldId xmlns:r="http://schemas.openxmlformats.org/officeDocument/2006/relationships" id="259" r:id="Rd97facb4f47b4221"/>
+    <p:sldId xmlns:r="http://schemas.openxmlformats.org/officeDocument/2006/relationships" id="260" r:id="R5b92d3e96022428f"/>
+    <p:sldId xmlns:r="http://schemas.openxmlformats.org/officeDocument/2006/relationships" id="261" r:id="Rca7bfcae863f42a3"/>
+    <p:sldId xmlns:r="http://schemas.openxmlformats.org/officeDocument/2006/relationships" id="262" r:id="R079cd6b0f9ad44c7"/>
+    <p:sldId xmlns:r="http://schemas.openxmlformats.org/officeDocument/2006/relationships" id="263" r:id="R2562bb31df3f4552"/>
+    <p:sldId xmlns:r="http://schemas.openxmlformats.org/officeDocument/2006/relationships" id="264" r:id="R261792efa7c4427a"/>
+    <p:sldId xmlns:r="http://schemas.openxmlformats.org/officeDocument/2006/relationships" id="265" r:id="R455dcd4601704d09"/>
   </p:sldIdLst>
   <p:sldSz cx="12192000" cy="6858000"/>
   <p:notesSz cx="6858000" cy="9144000"/>
@@ -546,7 +546,7 @@
           <a:lstStyle xmlns:a="http://schemas.openxmlformats.org/drawingml/2006/main"/>
           <a:p xmlns:a="http://schemas.openxmlformats.org/drawingml/2006/main">
             <a:r>
-              <a:t>Open by connecting directly to Lesson 1. Lesson 1 taught that the model reads one visible paper. Lesson 2 asks how we scale the prompts that prepare that paper without pasting every rule into every turn.</a:t>
+              <a:t>Lesson 2 starts where Lesson 1 ended: prompts are written onto a limited paper. This lesson is about scaling prompt-like instructions without crowding the same context.</a:t>
             </a:r>
           </a:p>
         </p:txBody>
@@ -616,7 +616,7 @@
           <a:lstStyle xmlns:a="http://schemas.openxmlformats.org/drawingml/2006/main"/>
           <a:p xmlns:a="http://schemas.openxmlformats.org/drawingml/2006/main">
             <a:r>
-              <a:t>Close the loop. Lesson 2 is about scaling custom prompts by packaging, isolating, and loading them just in time. Lesson 2.1 goes deeper into runtime objects; Lesson 3 handles multi-agent workflows.</a:t>
+              <a:t>Close with the operating model: prompt engineering writes instructions; context architecture decides where those instructions travel.</a:t>
             </a:r>
           </a:p>
         </p:txBody>
@@ -686,7 +686,7 @@
           <a:lstStyle xmlns:a="http://schemas.openxmlformats.org/drawingml/2006/main"/>
           <a:p xmlns:a="http://schemas.openxmlformats.org/drawingml/2006/main">
             <a:r>
-              <a:t>Make the pain concrete. Custom prompts work, but repeated copying creates token cost, drift, duplication, and maintenance problems. This sets up the need for packaging, splitting, and dynamic loading.</a:t>
+              <a:t>Show why copy-pasting custom prompts breaks down. The model still only sees one paper, so duplicated rules compete with the actual task.</a:t>
             </a:r>
           </a:p>
         </p:txBody>
@@ -756,7 +756,7 @@
           <a:lstStyle xmlns:a="http://schemas.openxmlformats.org/drawingml/2006/main"/>
           <a:p xmlns:a="http://schemas.openxmlformats.org/drawingml/2006/main">
             <a:r>
-              <a:t>Define a custom agent as the reusable package for stable role instructions. It is a custom prompt plus a runtime profile: role, rules, tools, permissions, boundaries, and quality bar.</a:t>
+              <a:t>A custom agent packages a stable role and working profile. Treat it as a reusable worker identity, not a longer one-off prompt.</a:t>
             </a:r>
           </a:p>
         </p:txBody>
@@ -826,7 +826,7 @@
           <a:lstStyle xmlns:a="http://schemas.openxmlformats.org/drawingml/2006/main"/>
           <a:p xmlns:a="http://schemas.openxmlformats.org/drawingml/2006/main">
             <a:r>
-              <a:t>Introduce subagents as separate working papers. A subagent may start from a shared task brief or forked context, then keeps its own local detail and returns a summary or artifact.</a:t>
+              <a:t>A subagent is a delegated worker with its own paper. The main thread sends a bounded brief and receives a summary or artifact back.</a:t>
             </a:r>
           </a:p>
         </p:txBody>
@@ -896,7 +896,7 @@
           <a:lstStyle xmlns:a="http://schemas.openxmlformats.org/drawingml/2006/main"/>
           <a:p xmlns:a="http://schemas.openxmlformats.org/drawingml/2006/main">
             <a:r>
-              <a:t>Contrast compaction with planned decomposition. Compaction compresses one evolving paper when it gets too full. Subagent decomposition proactively assigns separate papers to weakly coupled branches.</a:t>
+              <a:t>Compaction compresses one crowded paper. Subagent decomposition proactively gives weakly coupled branches their own papers before detail is compressed away.</a:t>
             </a:r>
           </a:p>
         </p:txBody>
@@ -966,7 +966,7 @@
           <a:lstStyle xmlns:a="http://schemas.openxmlformats.org/drawingml/2006/main"/>
           <a:p xmlns:a="http://schemas.openxmlformats.org/drawingml/2006/main">
             <a:r>
-              <a:t>Give the audience the operating rule. Subagents work best when tasks have clear boundaries, can run independently for a while, and can merge through a summary, file, finding list, or checkpoint.</a:t>
+              <a:t>Subagents work best when local papers can make progress and rejoin through a clear merge artifact. Coupling is a synchronization question, not an automatic ban.</a:t>
             </a:r>
           </a:p>
         </p:txBody>
@@ -1036,7 +1036,7 @@
           <a:lstStyle xmlns:a="http://schemas.openxmlformats.org/drawingml/2006/main"/>
           <a:p xmlns:a="http://schemas.openxmlformats.org/drawingml/2006/main">
             <a:r>
-              <a:t>Define a skill as a just-in-time prompt/manual pack. Use it when you cannot know up front whether a specific checklist, template, or method will be needed in this task.</a:t>
+              <a:t>Skills solve the conditional-loading problem. Keep a method outside the paper until the task actually needs that manual or checklist.</a:t>
             </a:r>
           </a:p>
         </p:txBody>
@@ -1106,7 +1106,7 @@
           <a:lstStyle xmlns:a="http://schemas.openxmlformats.org/drawingml/2006/main"/>
           <a:p xmlns:a="http://schemas.openxmlformats.org/drawingml/2006/main">
             <a:r>
-              <a:t>Show that a skill is more than a prompt. It can sit beside scripts, templates, examples, schemas, and references so a repeated capability is organized as a small tool kit.</a:t>
+              <a:t>A skill can be a small capability kit. It can keep workflow instructions, scripts, examples, templates, and references together.</a:t>
             </a:r>
           </a:p>
         </p:txBody>
@@ -1176,7 +1176,7 @@
           <a:lstStyle xmlns:a="http://schemas.openxmlformats.org/drawingml/2006/main"/>
           <a:p xmlns:a="http://schemas.openxmlformats.org/drawingml/2006/main">
             <a:r>
-              <a:t>Summarize the selection logic. Stable role goes into a custom agent. Independent branch goes to a subagent. Conditional method goes into a skill. One-off detail stays in the current prompt.</a:t>
+              <a:t>This slide gives the selection rule: one-off prompt, custom agent, subagent, and skill each solve a different context-loading problem.</a:t>
             </a:r>
           </a:p>
         </p:txBody>
@@ -1244,7 +1244,7 @@
   </p:cSld>
   <p:clrMap bg1="lt1" tx1="dk1" bg2="lt2" tx2="dk2" accent1="accent1" accent2="accent2" accent3="accent3" accent4="accent4" accent5="accent5" accent6="accent6" hlink="hlink" folHlink="folHlink"/>
   <p:sldLayoutIdLst>
-    <p:sldLayoutId xmlns:r="http://schemas.openxmlformats.org/officeDocument/2006/relationships" id="2147483649" r:id="R4b1ecde082de4db2"/>
+    <p:sldLayoutId xmlns:r="http://schemas.openxmlformats.org/officeDocument/2006/relationships" id="2147483649" r:id="Rbf431e864fdc4ea1"/>
   </p:sldLayoutIdLst>
   <p:txStyles>
     <p:titleStyle>
@@ -1799,7 +1799,7 @@
           <p:nvPr/>
         </p:nvPicPr>
         <p:blipFill>
-          <a:blip xmlns:r="http://schemas.openxmlformats.org/officeDocument/2006/relationships" xmlns:a="http://schemas.openxmlformats.org/drawingml/2006/main" r:embed="Rda51026ce67044ac"/>
+          <a:blip xmlns:r="http://schemas.openxmlformats.org/officeDocument/2006/relationships" xmlns:a="http://schemas.openxmlformats.org/drawingml/2006/main" r:embed="R5b2e6013ac1b4b2a"/>
           <a:stretch xmlns:a="http://schemas.openxmlformats.org/drawingml/2006/main"/>
         </p:blipFill>
         <p:spPr>
@@ -1815,7 +1815,7 @@
     </p:spTree>
     <p:extLst>
       <p:ext uri="{BB962C8B-B14F-4D97-AF65-F5344CB8AC3E}">
-        <p14:creationId xmlns:p14="http://schemas.microsoft.com/office/powerpoint/2010/main" val="1434409942"/>
+        <p14:creationId xmlns:p14="http://schemas.microsoft.com/office/powerpoint/2010/main" val="890390819"/>
       </p:ext>
     </p:extLst>
   </p:cSld>
@@ -1850,7 +1850,7 @@
           <p:nvPr/>
         </p:nvPicPr>
         <p:blipFill>
-          <a:blip xmlns:r="http://schemas.openxmlformats.org/officeDocument/2006/relationships" xmlns:a="http://schemas.openxmlformats.org/drawingml/2006/main" r:embed="R8b130f9612454945"/>
+          <a:blip xmlns:r="http://schemas.openxmlformats.org/officeDocument/2006/relationships" xmlns:a="http://schemas.openxmlformats.org/drawingml/2006/main" r:embed="Rf66c1e806393456b"/>
           <a:stretch xmlns:a="http://schemas.openxmlformats.org/drawingml/2006/main"/>
         </p:blipFill>
         <p:spPr>
@@ -1866,7 +1866,7 @@
     </p:spTree>
     <p:extLst>
       <p:ext uri="{BB962C8B-B14F-4D97-AF65-F5344CB8AC3E}">
-        <p14:creationId xmlns:p14="http://schemas.microsoft.com/office/powerpoint/2010/main" val="1224810254"/>
+        <p14:creationId xmlns:p14="http://schemas.microsoft.com/office/powerpoint/2010/main" val="678593199"/>
       </p:ext>
     </p:extLst>
   </p:cSld>
@@ -1901,7 +1901,7 @@
           <p:nvPr/>
         </p:nvPicPr>
         <p:blipFill>
-          <a:blip xmlns:r="http://schemas.openxmlformats.org/officeDocument/2006/relationships" xmlns:a="http://schemas.openxmlformats.org/drawingml/2006/main" r:embed="R7fb296632b3c4555"/>
+          <a:blip xmlns:r="http://schemas.openxmlformats.org/officeDocument/2006/relationships" xmlns:a="http://schemas.openxmlformats.org/drawingml/2006/main" r:embed="R73941316e73c46d0"/>
           <a:stretch xmlns:a="http://schemas.openxmlformats.org/drawingml/2006/main"/>
         </p:blipFill>
         <p:spPr>
@@ -1917,7 +1917,7 @@
     </p:spTree>
     <p:extLst>
       <p:ext uri="{BB962C8B-B14F-4D97-AF65-F5344CB8AC3E}">
-        <p14:creationId xmlns:p14="http://schemas.microsoft.com/office/powerpoint/2010/main" val="849229220"/>
+        <p14:creationId xmlns:p14="http://schemas.microsoft.com/office/powerpoint/2010/main" val="402447717"/>
       </p:ext>
     </p:extLst>
   </p:cSld>
@@ -1952,7 +1952,7 @@
           <p:nvPr/>
         </p:nvPicPr>
         <p:blipFill>
-          <a:blip xmlns:r="http://schemas.openxmlformats.org/officeDocument/2006/relationships" xmlns:a="http://schemas.openxmlformats.org/drawingml/2006/main" r:embed="R6518b76d61864880"/>
+          <a:blip xmlns:r="http://schemas.openxmlformats.org/officeDocument/2006/relationships" xmlns:a="http://schemas.openxmlformats.org/drawingml/2006/main" r:embed="R84cc150a8126455d"/>
           <a:stretch xmlns:a="http://schemas.openxmlformats.org/drawingml/2006/main"/>
         </p:blipFill>
         <p:spPr>
@@ -1968,7 +1968,7 @@
     </p:spTree>
     <p:extLst>
       <p:ext uri="{BB962C8B-B14F-4D97-AF65-F5344CB8AC3E}">
-        <p14:creationId xmlns:p14="http://schemas.microsoft.com/office/powerpoint/2010/main" val="1139984199"/>
+        <p14:creationId xmlns:p14="http://schemas.microsoft.com/office/powerpoint/2010/main" val="1011599420"/>
       </p:ext>
     </p:extLst>
   </p:cSld>
@@ -2003,7 +2003,7 @@
           <p:nvPr/>
         </p:nvPicPr>
         <p:blipFill>
-          <a:blip xmlns:r="http://schemas.openxmlformats.org/officeDocument/2006/relationships" xmlns:a="http://schemas.openxmlformats.org/drawingml/2006/main" r:embed="R9613a76ca9c44499"/>
+          <a:blip xmlns:r="http://schemas.openxmlformats.org/officeDocument/2006/relationships" xmlns:a="http://schemas.openxmlformats.org/drawingml/2006/main" r:embed="R6863c5bfb01c49c3"/>
           <a:stretch xmlns:a="http://schemas.openxmlformats.org/drawingml/2006/main"/>
         </p:blipFill>
         <p:spPr>
@@ -2019,7 +2019,7 @@
     </p:spTree>
     <p:extLst>
       <p:ext uri="{BB962C8B-B14F-4D97-AF65-F5344CB8AC3E}">
-        <p14:creationId xmlns:p14="http://schemas.microsoft.com/office/powerpoint/2010/main" val="1036447640"/>
+        <p14:creationId xmlns:p14="http://schemas.microsoft.com/office/powerpoint/2010/main" val="1959251133"/>
       </p:ext>
     </p:extLst>
   </p:cSld>
@@ -2054,7 +2054,7 @@
           <p:nvPr/>
         </p:nvPicPr>
         <p:blipFill>
-          <a:blip xmlns:r="http://schemas.openxmlformats.org/officeDocument/2006/relationships" xmlns:a="http://schemas.openxmlformats.org/drawingml/2006/main" r:embed="R5686607bb47543a3"/>
+          <a:blip xmlns:r="http://schemas.openxmlformats.org/officeDocument/2006/relationships" xmlns:a="http://schemas.openxmlformats.org/drawingml/2006/main" r:embed="Rbb1b322e29c640fc"/>
           <a:stretch xmlns:a="http://schemas.openxmlformats.org/drawingml/2006/main"/>
         </p:blipFill>
         <p:spPr>
@@ -2070,7 +2070,7 @@
     </p:spTree>
     <p:extLst>
       <p:ext uri="{BB962C8B-B14F-4D97-AF65-F5344CB8AC3E}">
-        <p14:creationId xmlns:p14="http://schemas.microsoft.com/office/powerpoint/2010/main" val="1861133344"/>
+        <p14:creationId xmlns:p14="http://schemas.microsoft.com/office/powerpoint/2010/main" val="1614057040"/>
       </p:ext>
     </p:extLst>
   </p:cSld>
@@ -2105,7 +2105,7 @@
           <p:nvPr/>
         </p:nvPicPr>
         <p:blipFill>
-          <a:blip xmlns:r="http://schemas.openxmlformats.org/officeDocument/2006/relationships" xmlns:a="http://schemas.openxmlformats.org/drawingml/2006/main" r:embed="Rfade758a1f934421"/>
+          <a:blip xmlns:r="http://schemas.openxmlformats.org/officeDocument/2006/relationships" xmlns:a="http://schemas.openxmlformats.org/drawingml/2006/main" r:embed="Rea45403810974161"/>
           <a:stretch xmlns:a="http://schemas.openxmlformats.org/drawingml/2006/main"/>
         </p:blipFill>
         <p:spPr>
@@ -2121,7 +2121,7 @@
     </p:spTree>
     <p:extLst>
       <p:ext uri="{BB962C8B-B14F-4D97-AF65-F5344CB8AC3E}">
-        <p14:creationId xmlns:p14="http://schemas.microsoft.com/office/powerpoint/2010/main" val="597908338"/>
+        <p14:creationId xmlns:p14="http://schemas.microsoft.com/office/powerpoint/2010/main" val="1619251396"/>
       </p:ext>
     </p:extLst>
   </p:cSld>
@@ -2156,7 +2156,7 @@
           <p:nvPr/>
         </p:nvPicPr>
         <p:blipFill>
-          <a:blip xmlns:r="http://schemas.openxmlformats.org/officeDocument/2006/relationships" xmlns:a="http://schemas.openxmlformats.org/drawingml/2006/main" r:embed="R9a635c348d674632"/>
+          <a:blip xmlns:r="http://schemas.openxmlformats.org/officeDocument/2006/relationships" xmlns:a="http://schemas.openxmlformats.org/drawingml/2006/main" r:embed="R7fdc68809daf40cf"/>
           <a:stretch xmlns:a="http://schemas.openxmlformats.org/drawingml/2006/main"/>
         </p:blipFill>
         <p:spPr>
@@ -2172,7 +2172,7 @@
     </p:spTree>
     <p:extLst>
       <p:ext uri="{BB962C8B-B14F-4D97-AF65-F5344CB8AC3E}">
-        <p14:creationId xmlns:p14="http://schemas.microsoft.com/office/powerpoint/2010/main" val="1009109976"/>
+        <p14:creationId xmlns:p14="http://schemas.microsoft.com/office/powerpoint/2010/main" val="1261882187"/>
       </p:ext>
     </p:extLst>
   </p:cSld>
@@ -2207,7 +2207,7 @@
           <p:nvPr/>
         </p:nvPicPr>
         <p:blipFill>
-          <a:blip xmlns:r="http://schemas.openxmlformats.org/officeDocument/2006/relationships" xmlns:a="http://schemas.openxmlformats.org/drawingml/2006/main" r:embed="R922b644e53764d3e"/>
+          <a:blip xmlns:r="http://schemas.openxmlformats.org/officeDocument/2006/relationships" xmlns:a="http://schemas.openxmlformats.org/drawingml/2006/main" r:embed="Re754319db2894b63"/>
           <a:stretch xmlns:a="http://schemas.openxmlformats.org/drawingml/2006/main"/>
         </p:blipFill>
         <p:spPr>
@@ -2223,7 +2223,7 @@
     </p:spTree>
     <p:extLst>
       <p:ext uri="{BB962C8B-B14F-4D97-AF65-F5344CB8AC3E}">
-        <p14:creationId xmlns:p14="http://schemas.microsoft.com/office/powerpoint/2010/main" val="1755097069"/>
+        <p14:creationId xmlns:p14="http://schemas.microsoft.com/office/powerpoint/2010/main" val="1331627721"/>
       </p:ext>
     </p:extLst>
   </p:cSld>
@@ -2258,7 +2258,7 @@
           <p:nvPr/>
         </p:nvPicPr>
         <p:blipFill>
-          <a:blip xmlns:r="http://schemas.openxmlformats.org/officeDocument/2006/relationships" xmlns:a="http://schemas.openxmlformats.org/drawingml/2006/main" r:embed="Rd52a205ad83c489d"/>
+          <a:blip xmlns:r="http://schemas.openxmlformats.org/officeDocument/2006/relationships" xmlns:a="http://schemas.openxmlformats.org/drawingml/2006/main" r:embed="R93e442d6bf714b68"/>
           <a:stretch xmlns:a="http://schemas.openxmlformats.org/drawingml/2006/main"/>
         </p:blipFill>
         <p:spPr>
@@ -2274,7 +2274,7 @@
     </p:spTree>
     <p:extLst>
       <p:ext uri="{BB962C8B-B14F-4D97-AF65-F5344CB8AC3E}">
-        <p14:creationId xmlns:p14="http://schemas.microsoft.com/office/powerpoint/2010/main" val="654273764"/>
+        <p14:creationId xmlns:p14="http://schemas.microsoft.com/office/powerpoint/2010/main" val="813983337"/>
       </p:ext>
     </p:extLst>
   </p:cSld>

</xml_diff>